<commit_message>
docs(U6): renombrar escenario 'Black Friday' a 'pico de ventas' en informe/PDF/presentacion y detallar navegacion paso a paso (Supabase/Atlas) en el guion del video
</commit_message>
<xml_diff>
--- a/Ecommify_Database_Design/docs/Presentacion_Ejecutiva_U6_Etapa_2.pptx
+++ b/Ecommify_Database_Design/docs/Presentacion_Ejecutiva_U6_Etapa_2.pptx
@@ -3662,7 +3662,7 @@
                 </a:solidFill>
                 <a:latin typeface="Calibri"/>
               </a:rPr>
-              <a:t>Black Friday</a:t>
+              <a:t>Pico de ventas</a:t>
             </a:r>
           </a:p>
         </p:txBody>
@@ -3701,7 +3701,7 @@
                 </a:solidFill>
                 <a:latin typeface="Calibri"/>
               </a:rPr>
-              <a:t>Pico de tráfico</a:t>
+              <a:t>Campaña de descuentos</a:t>
             </a:r>
           </a:p>
         </p:txBody>

</xml_diff>